<commit_message>
Add team members and presenter assignments
</commit_message>
<xml_diff>
--- a/presentation/Tayseer_Capstone_Executive_Story.pptx
+++ b/presentation/Tayseer_Capstone_Executive_Story.pptx
@@ -508,7 +508,7 @@
           <a:lstStyle/>
           <a:p>
             <a:r>
-              <a:t>PRESENTER: Student 1  (0:00–0:30)</a:t>
+              <a:t>PRESENTER: Yousef Almutairi  (0:00–0:30)</a:t>
             </a:r>
           </a:p>
           <a:p/>
@@ -594,7 +594,7 @@
           <a:lstStyle/>
           <a:p>
             <a:r>
-              <a:t>PRESENTER: Student 1  (0:30–1:15)</a:t>
+              <a:t>PRESENTER: Yousef Almutairi  (0:30–1:15)</a:t>
             </a:r>
           </a:p>
           <a:p/>
@@ -680,7 +680,7 @@
           <a:lstStyle/>
           <a:p>
             <a:r>
-              <a:t>PRESENTER: Student 2  (1:15–2:00)</a:t>
+              <a:t>PRESENTER: Abdulwahab Alnassar  (1:15–2:00)</a:t>
             </a:r>
           </a:p>
           <a:p/>
@@ -771,7 +771,7 @@
           <a:lstStyle/>
           <a:p>
             <a:r>
-              <a:t>PRESENTER: Student 2  (2:00–4:00)</a:t>
+              <a:t>PRESENTER: Abdulwahab Alnassar  (2:00–4:00)</a:t>
             </a:r>
           </a:p>
           <a:p/>
@@ -867,7 +867,7 @@
           <a:lstStyle/>
           <a:p>
             <a:r>
-              <a:t>PRESENTER: Student 3  (4:00–5:00)</a:t>
+              <a:t>PRESENTER: Firas Alnasser  (4:00–5:00)</a:t>
             </a:r>
           </a:p>
           <a:p/>
@@ -963,7 +963,7 @@
           <a:lstStyle/>
           <a:p>
             <a:r>
-              <a:t>PRESENTER: Student 3  (5:00–6:15)</a:t>
+              <a:t>PRESENTER: Firas Alnasser  (5:00–6:15)</a:t>
             </a:r>
           </a:p>
           <a:p/>
@@ -1059,7 +1059,7 @@
           <a:lstStyle/>
           <a:p>
             <a:r>
-              <a:t>PRESENTER: Student 3  (6:15–7:00)</a:t>
+              <a:t>PRESENTER: Firas Alnasser  (6:15–7:00)</a:t>
             </a:r>
           </a:p>
           <a:p/>

</xml_diff>

<commit_message>
Move plan timeline to 2026–2027; correct dashboard views in README
</commit_message>
<xml_diff>
--- a/presentation/Tayseer_Capstone_Executive_Story.pptx
+++ b/presentation/Tayseer_Capstone_Executive_Story.pptx
@@ -2169,7 +2169,7 @@
             <a:r>
               <a:rPr lang="en-US" dirty="0"/>
               <a:t>PRESENTER: Yousef (0:00–0:30)
-State the ask in the first 30 seconds: approve SAR 40M for Najran, Northern Borders, Al-Baha and Jazan. National is above 65%, these four are stuck; Najran would need almost two years. Money released in two tranches with a June 2026 checkpoint.</a:t>
+State the ask in the first 30 seconds: approve SAR 40M for Najran, Northern Borders, Al-Baha and Jazan. National is above 65%, these four are stuck; Najran would need almost two years. Money released in two tranches with a June 2027 checkpoint.</a:t>
             </a:r>
             <a:endParaRPr lang="en-US" dirty="0"/>
           </a:p>
@@ -2622,7 +2622,7 @@
               <a:t>PRESENTER: Firas (5:00–6:15)
 Split follows users still to convert: Najran 15, Northern Borders 9, Al-Baha 8, Jazan 8.
 The money buys: digitise Complaints &amp; Permits; assisted-digital desks in branches (53% vs 75% app); local onboarding.
-Effect: all four at 65% by Dec 2026; Najran must roughly double its pace (0.19 → 0.34 pts/month), otherwise ~Sep 2027.
+Effect: all four at 65% by Dec 2027; Najran must roughly double its pace (0.19 → 0.34 pts/month), otherwise ~Sep 2028.
 Uncertainty: data shows where the gap is, not points per million, hence staged release.</a:t>
             </a:r>
             <a:endParaRPr lang="en-US" dirty="0"/>
@@ -2712,7 +2712,7 @@
             <a:r>
               <a:rPr lang="en-US" dirty="0"/>
               <a:t>PRESENTER: Firas (6:15–7:00)
-Restate the ask: approve SAR 40M for Najran, Northern Borders, Al-Baha and Jazan; SAR 20M now, SAR 20M in June 2026 if each region is at least halfway to 65%. Tracked monthly on the Tableau dashboard; a missed checkpoint re-targets that region's tranche.
+Restate the ask: approve SAR 40M for Najran, Northern Borders, Al-Baha and Jazan; SAR 20M now, SAR 20M in June 2027 if each region is at least halfway to 65%. Tracked monthly on the Tableau dashboard; a missed checkpoint re-targets that region's tranche.
 Close: Nationally we hit 65%. This decision makes sure every region does.</a:t>
             </a:r>
             <a:endParaRPr lang="en-US" dirty="0"/>
@@ -3954,7 +3954,7 @@
                 <a:ea typeface="Calibri" pitchFamily="34" charset="-122"/>
                 <a:cs typeface="Calibri" pitchFamily="34" charset="-120"/>
               </a:rPr>
-              <a:t>Tayseer has met the 65% target nationally, but four regions are stuck below it. Putting the full SAR 40M there brings all four to 65% by Dec 2026 instead of as late as 2027.</a:t>
+              <a:t>Tayseer has met the 65% target nationally, but four regions are stuck below it. Putting the full SAR 40M there brings all four to 65% by Dec 2027 instead of as late as 2028.</a:t>
             </a:r>
             <a:endParaRPr lang="en-US" sz="1600" dirty="0"/>
           </a:p>
@@ -4675,7 +4675,7 @@
                 <a:ea typeface="Calibri" pitchFamily="34" charset="-122"/>
                 <a:cs typeface="Calibri" pitchFamily="34" charset="-120"/>
               </a:rPr>
-              <a:t>SAR 20M now  ·  SAR 20M after a June 2026 checkpoint</a:t>
+              <a:t>SAR 20M now  ·  SAR 20M after a June 2027 checkpoint</a:t>
             </a:r>
             <a:endParaRPr lang="en-US" sz="1500" dirty="0"/>
           </a:p>
@@ -10526,7 +10526,7 @@
                 <a:ea typeface="Calibri" pitchFamily="34" charset="-122"/>
                 <a:cs typeface="Calibri" pitchFamily="34" charset="-120"/>
               </a:rPr>
-              <a:t>Weight the SAR 40M by gap size and bring all four regions to 65% by December 2026</a:t>
+              <a:t>Weight the SAR 40M by gap size and bring all four regions to 65% by December 2027</a:t>
             </a:r>
             <a:endParaRPr lang="en-US" sz="2800" dirty="0"/>
           </a:p>
@@ -11422,7 +11422,7 @@
                 <a:ea typeface="Calibri" pitchFamily="34" charset="-122"/>
                 <a:cs typeface="Calibri" pitchFamily="34" charset="-120"/>
               </a:rPr>
-              <a:t>Dec 2026</a:t>
+              <a:t>Dec 2027</a:t>
             </a:r>
             <a:endParaRPr lang="en-US" sz="2600" dirty="0"/>
           </a:p>
@@ -11478,7 +11478,7 @@
                 <a:ea typeface="Calibri" pitchFamily="34" charset="-122"/>
                 <a:cs typeface="Calibri" pitchFamily="34" charset="-120"/>
               </a:rPr>
-              <a:t>Sep 2027</a:t>
+              <a:t>Sep 2028</a:t>
             </a:r>
             <a:endParaRPr lang="en-US" sz="2600" dirty="0"/>
           </a:p>
@@ -12164,7 +12164,7 @@
                 <a:ea typeface="Calibri" pitchFamily="34" charset="-122"/>
                 <a:cs typeface="Calibri" pitchFamily="34" charset="-120"/>
               </a:rPr>
-              <a:t>Approve SAR 40M today, released in two tranches with a June 2026 checkpoint</a:t>
+              <a:t>Approve SAR 40M today, released in two tranches with a June 2027 checkpoint</a:t>
             </a:r>
             <a:endParaRPr lang="en-US" sz="2800" dirty="0"/>
           </a:p>
@@ -12371,7 +12371,7 @@
                 <a:ea typeface="Calibri" pitchFamily="34" charset="-122"/>
                 <a:cs typeface="Calibri" pitchFamily="34" charset="-120"/>
               </a:rPr>
-              <a:t>Q1 – Q2 2026</a:t>
+              <a:t>Q1 – Q2 2027</a:t>
             </a:r>
             <a:endParaRPr lang="en-US" sz="1100" dirty="0"/>
           </a:p>
@@ -12491,7 +12491,7 @@
                 <a:ea typeface="Calibri" pitchFamily="34" charset="-122"/>
                 <a:cs typeface="Calibri" pitchFamily="34" charset="-120"/>
               </a:rPr>
-              <a:t>JUNE 2026</a:t>
+              <a:t>JUNE 2027</a:t>
             </a:r>
             <a:endParaRPr lang="en-US" sz="1100" dirty="0"/>
           </a:p>
@@ -12611,7 +12611,7 @@
                 <a:ea typeface="Calibri" pitchFamily="34" charset="-122"/>
                 <a:cs typeface="Calibri" pitchFamily="34" charset="-120"/>
               </a:rPr>
-              <a:t>DEC 2026</a:t>
+              <a:t>DEC 2027</a:t>
             </a:r>
             <a:endParaRPr lang="en-US" sz="1100" dirty="0"/>
           </a:p>
@@ -12706,7 +12706,7 @@
                 <a:ea typeface="Calibri" pitchFamily="34" charset="-122"/>
                 <a:cs typeface="Calibri" pitchFamily="34" charset="-120"/>
               </a:rPr>
-              <a:t>June 2026 checkpoint: halfway to 65%</a:t>
+              <a:t>June 2027 checkpoint: halfway to 65%</a:t>
             </a:r>
             <a:endParaRPr lang="en-US" sz="1500" dirty="0"/>
           </a:p>
@@ -12894,7 +12894,7 @@
                           <a:ea typeface="Calibri" pitchFamily="34" charset="-122"/>
                           <a:cs typeface="Calibri" pitchFamily="34" charset="-120"/>
                         </a:rPr>
-                        <a:t>Must reach by Jun 2026</a:t>
+                        <a:t>Must reach by Jun 2027</a:t>
                       </a:r>
                       <a:endParaRPr lang="en-US" sz="1300" dirty="0">
                         <a:latin typeface="Calibri" charset="0"/>

</xml_diff>

<commit_message>
Use year-over-year pace to match Tableau; plan starts Q4 2026
</commit_message>
<xml_diff>
--- a/presentation/Tayseer_Capstone_Executive_Story.pptx
+++ b/presentation/Tayseer_Capstone_Executive_Story.pptx
@@ -1277,10 +1277,10 @@
                     <c:v>Northern Borders</c:v>
                   </c:pt>
                   <c:pt idx="2">
-                    <c:v>Al-Baha</c:v>
+                    <c:v>Jazan</c:v>
                   </c:pt>
                   <c:pt idx="3">
-                    <c:v>Jazan</c:v>
+                    <c:v>Al-Baha</c:v>
                   </c:pt>
                   <c:pt idx="4">
                     <c:v>Asir</c:v>
@@ -1305,13 +1305,13 @@
                 <c:formatCode>General</c:formatCode>
                 <c:ptCount val="8"/>
                 <c:pt idx="0">
-                  <c:v>21</c:v>
+                  <c:v>19</c:v>
                 </c:pt>
                 <c:pt idx="1">
-                  <c:v>10</c:v>
+                  <c:v>11</c:v>
                 </c:pt>
                 <c:pt idx="2">
-                  <c:v>9</c:v>
+                  <c:v>8</c:v>
                 </c:pt>
                 <c:pt idx="3">
                   <c:v>7</c:v>
@@ -2169,7 +2169,7 @@
             <a:r>
               <a:rPr lang="en-US" dirty="0"/>
               <a:t>PRESENTER: Yousef (0:00–0:30)
-State the ask in the first 30 seconds: approve SAR 40M for Najran, Northern Borders, Al-Baha and Jazan. National is above 65%, these four are stuck; Najran would need almost two years. Money released in two tranches with a June 2027 checkpoint.</a:t>
+State the ask in the first 30 seconds: approve SAR 40M for Najran, Northern Borders, Al-Baha and Jazan. National is above 65%, these four are stuck; Najran would need over a year and a half. Money released in two tranches with a June 2027 checkpoint.</a:t>
             </a:r>
             <a:endParaRPr lang="en-US" dirty="0"/>
           </a:p>
@@ -2439,9 +2439,9 @@
               <a:rPr lang="en-US" dirty="0"/>
               <a:t>PRESENTER: Abdulwahab (2:00–4:00)
 Orient: only the 8 below-target regions; bar = months to reach 65% at the 2025 pace.
-Grey four (Al-Jouf, Hail, Tabuk, Asir) cross within ~3 months on their own. Orange four need 7–21 months; Najran has the biggest gap and slowest pace.
+Grey four (Al-Jouf, Hail, Tabuk, Asir) cross within ~3 months on their own. Orange four need 7–19 months; Najran has the biggest gap and slowest pace.
 Right panel: Complaints is the weakest journey (56.8% vs 62.1% nationally).
-Method: pace = linear trend of 2025; adoption is user-weighted, same as the Tableau field.</a:t>
+Method: pace = change Dec 2024 → Dec 2025 ÷ 12; same fields as the Tableau Months to Target sheet.</a:t>
             </a:r>
             <a:endParaRPr lang="en-US" dirty="0"/>
           </a:p>
@@ -2622,7 +2622,7 @@
               <a:t>PRESENTER: Firas (5:00–6:15)
 Split follows users still to convert: Najran 15, Northern Borders 9, Al-Baha 8, Jazan 8.
 The money buys: digitise Complaints &amp; Permits; assisted-digital desks in branches (53% vs 75% app); local onboarding.
-Effect: all four at 65% by Dec 2027; Najran must roughly double its pace (0.19 → 0.34 pts/month), otherwise ~Sep 2028.
+Effect: all four at 65% by Dec 2027; Najran must lift its pace ~60% (0.21 → 0.34 pts/month), otherwise ~Jul 2028.
 Uncertainty: data shows where the gap is, not points per million, hence staged release.</a:t>
             </a:r>
             <a:endParaRPr lang="en-US" dirty="0"/>
@@ -4121,7 +4121,7 @@
                 <a:ea typeface="Calibri" pitchFamily="34" charset="-122"/>
                 <a:cs typeface="Calibri" pitchFamily="34" charset="-120"/>
               </a:rPr>
-              <a:t>21 months to reach 65% on current pace</a:t>
+              <a:t>19 months to reach 65% on current pace</a:t>
             </a:r>
             <a:endParaRPr lang="en-US" sz="1250" dirty="0"/>
           </a:p>
@@ -4288,7 +4288,7 @@
                 <a:ea typeface="Calibri" pitchFamily="34" charset="-122"/>
                 <a:cs typeface="Calibri" pitchFamily="34" charset="-120"/>
               </a:rPr>
-              <a:t>10 months to reach 65% on current pace</a:t>
+              <a:t>11 months to reach 65% on current pace</a:t>
             </a:r>
             <a:endParaRPr lang="en-US" sz="1250" dirty="0"/>
           </a:p>
@@ -4455,7 +4455,7 @@
                 <a:ea typeface="Calibri" pitchFamily="34" charset="-122"/>
                 <a:cs typeface="Calibri" pitchFamily="34" charset="-120"/>
               </a:rPr>
-              <a:t>9 months to reach 65% on current pace</a:t>
+              <a:t>7 months to reach 65% on current pace</a:t>
             </a:r>
             <a:endParaRPr lang="en-US" sz="1250" dirty="0"/>
           </a:p>
@@ -4622,7 +4622,7 @@
                 <a:ea typeface="Calibri" pitchFamily="34" charset="-122"/>
                 <a:cs typeface="Calibri" pitchFamily="34" charset="-120"/>
               </a:rPr>
-              <a:t>7 months to reach 65% on current pace</a:t>
+              <a:t>8 months to reach 65% on current pace</a:t>
             </a:r>
             <a:endParaRPr lang="en-US" sz="1250" dirty="0"/>
           </a:p>
@@ -7510,7 +7510,7 @@
                 <a:ea typeface="Calibri" pitchFamily="34" charset="-122"/>
                 <a:cs typeface="Calibri" pitchFamily="34" charset="-120"/>
               </a:rPr>
-              <a:t>Four regions will reach 65% on their own within 3 months; four will not, and Najran needs 21</a:t>
+              <a:t>Four regions will reach 65% on their own within 3 months; four will not, and Najran needs 19</a:t>
             </a:r>
             <a:endParaRPr lang="en-US" sz="2800" dirty="0"/>
           </a:p>
@@ -7929,7 +7929,7 @@
                 <a:ea typeface="Calibri" pitchFamily="34" charset="-122"/>
                 <a:cs typeface="Calibri" pitchFamily="34" charset="-120"/>
               </a:rPr>
-              <a:t>+0.19 pts / month</a:t>
+              <a:t>+0.21 pts / month</a:t>
             </a:r>
             <a:endParaRPr lang="en-US" sz="2000" dirty="0"/>
           </a:p>
@@ -7949,7 +7949,7 @@
                 <a:ea typeface="Calibri" pitchFamily="34" charset="-122"/>
                 <a:cs typeface="Calibri" pitchFamily="34" charset="-120"/>
               </a:rPr>
-              <a:t>Najran's pace: the slowest of any region, with the biggest gap</a:t>
+              <a:t>Najran: biggest gap, below-average pace</a:t>
             </a:r>
             <a:endParaRPr lang="en-US" sz="2000" dirty="0"/>
           </a:p>
@@ -9331,7 +9331,7 @@
                 <a:ea typeface="Calibri" pitchFamily="34" charset="-122"/>
                 <a:cs typeface="Calibri" pitchFamily="34" charset="-120"/>
               </a:rPr>
-              <a:t>100% of the budget reaches regions needing 7–21 months</a:t>
+              <a:t>100% of the budget reaches regions needing 7–19 months</a:t>
             </a:r>
             <a:endParaRPr lang="en-US" sz="1300" dirty="0"/>
           </a:p>
@@ -11478,7 +11478,7 @@
                 <a:ea typeface="Calibri" pitchFamily="34" charset="-122"/>
                 <a:cs typeface="Calibri" pitchFamily="34" charset="-120"/>
               </a:rPr>
-              <a:t>Sep 2028</a:t>
+              <a:t>Jul 2028</a:t>
             </a:r>
             <a:endParaRPr lang="en-US" sz="2600" dirty="0"/>
           </a:p>
@@ -11534,7 +11534,7 @@
                 <a:ea typeface="Calibri" pitchFamily="34" charset="-122"/>
                 <a:cs typeface="Calibri" pitchFamily="34" charset="-120"/>
               </a:rPr>
-              <a:t>0.19 → 0.34</a:t>
+              <a:t>0.21 → 0.34</a:t>
             </a:r>
             <a:endParaRPr lang="en-US" sz="2600" dirty="0"/>
           </a:p>
@@ -12251,7 +12251,7 @@
                 <a:ea typeface="Calibri" pitchFamily="34" charset="-122"/>
                 <a:cs typeface="Calibri" pitchFamily="34" charset="-120"/>
               </a:rPr>
-              <a:t>TODAY</a:t>
+              <a:t>Q4 2026</a:t>
             </a:r>
             <a:endParaRPr lang="en-US" sz="1100" dirty="0"/>
           </a:p>

</xml_diff>